<commit_message>
Fix Tailwind v4 dark mode variant to use class instead of media query
</commit_message>
<xml_diff>
--- a/Dukaan_Saathi_Pitch.pptx
+++ b/Dukaan_Saathi_Pitch.pptx
@@ -4,6 +4,9 @@
   <p:sldMasterIdLst>
     <p:sldMasterId id="2147483648" r:id="rId1"/>
   </p:sldMasterIdLst>
+  <p:notesMasterIdLst>
+    <p:notesMasterId r:id="rId12"/>
+  </p:notesMasterIdLst>
   <p:sldIdLst>
     <p:sldId id="256" r:id="rId2"/>
     <p:sldId id="257" r:id="rId3"/>
@@ -16,10 +19,7 @@
     <p:sldId id="264" r:id="rId10"/>
     <p:sldId id="265" r:id="rId11"/>
   </p:sldIdLst>
-  <p:notesMasterIdLst>
-    <p:notesMasterId r:id="rId12"/>
-  </p:notesMasterIdLst>
-  <p:sldSz cx="9144000" cy="5143500"/>
+  <p:sldSz cx="9144000" cy="5143500" type="screen16x9"/>
   <p:notesSz cx="5143500" cy="9144000"/>
   <p:defaultTextStyle>
     <a:lvl1pPr marL="0" algn="l" defTabSz="914400" rtl="0" eaLnBrk="1" latinLnBrk="0" hangingPunct="1">
@@ -113,6 +113,11 @@
       </a:defRPr>
     </a:lvl9pPr>
   </p:defaultTextStyle>
+  <p:extLst>
+    <p:ext uri="{EFAFB233-063F-42B5-8137-9DF3F51BA10A}">
+      <p15:sldGuideLst xmlns:p15="http://schemas.microsoft.com/office/powerpoint/2012/main"/>
+    </p:ext>
+  </p:extLst>
 </p:presentation>
 </file>
 
@@ -138,234 +143,10 @@
           <a:chExt cx="0" cy="0"/>
         </a:xfrm>
       </p:grpSpPr>
-      <p:sp>
-        <p:nvSpPr>
-          <p:cNvPr id="2" name="Header Placeholder 1"/>
-          <p:cNvSpPr>
-            <a:spLocks noGrp="1"/>
-          </p:cNvSpPr>
-          <p:nvPr>
-            <p:ph type="hdr" sz="quarter"/>
-          </p:nvPr>
-        </p:nvSpPr>
-        <p:spPr>
-          <a:xfrm>
-            <a:off x="0" y="0"/>
-            <a:ext cx="2971800" cy="458788"/>
-          </a:xfrm>
-          <a:prstGeom prst="rect">
-            <a:avLst/>
-          </a:prstGeom>
-        </p:spPr>
-        <p:txBody>
-          <a:bodyPr vert="horz" lIns="91440" tIns="45720" rIns="91440" bIns="45720" rtlCol="0"/>
-          <a:lstStyle>
-            <a:lvl1pPr algn="l">
-              <a:defRPr sz="1200"/>
-            </a:lvl1pPr>
-          </a:lstStyle>
-          <a:p>
-            <a:endParaRPr lang="en-US"/>
-          </a:p>
-        </p:txBody>
-      </p:sp>
-      <p:sp>
-        <p:nvSpPr>
-          <p:cNvPr id="3" name="Date Placeholder 2"/>
-          <p:cNvSpPr>
-            <a:spLocks noGrp="1"/>
-          </p:cNvSpPr>
-          <p:nvPr>
-            <p:ph type="dt" idx="1"/>
-          </p:nvPr>
-        </p:nvSpPr>
-        <p:spPr>
-          <a:xfrm>
-            <a:off x="3884613" y="0"/>
-            <a:ext cx="2971800" cy="458788"/>
-          </a:xfrm>
-          <a:prstGeom prst="rect">
-            <a:avLst/>
-          </a:prstGeom>
-        </p:spPr>
-        <p:txBody>
-          <a:bodyPr vert="horz" lIns="91440" tIns="45720" rIns="91440" bIns="45720" rtlCol="0"/>
-          <a:lstStyle>
-            <a:lvl1pPr algn="r">
-              <a:defRPr sz="1200"/>
-            </a:lvl1pPr>
-          </a:lstStyle>
-          <a:p>
-            <a:fld id="{5282F153-3F37-0F45-9E97-73ACFA13230C}" type="datetimeFigureOut">
-              <a:rPr lang="en-US"/>
-              <a:t>7/23/19</a:t>
-            </a:fld>
-            <a:endParaRPr lang="en-US"/>
-          </a:p>
-        </p:txBody>
-      </p:sp>
-      <p:sp>
-        <p:nvSpPr>
-          <p:cNvPr id="4" name="Slide Image Placeholder 3"/>
-          <p:cNvSpPr>
-            <a:spLocks noGrp="1" noRot="1" noChangeAspect="1"/>
-          </p:cNvSpPr>
-          <p:nvPr>
-            <p:ph type="sldImg" idx="2"/>
-          </p:nvPr>
-        </p:nvSpPr>
-        <p:spPr>
-          <a:xfrm>
-            <a:off x="685800" y="1143000"/>
-            <a:ext cx="5486400" cy="3086100"/>
-          </a:xfrm>
-          <a:prstGeom prst="rect">
-            <a:avLst/>
-          </a:prstGeom>
-          <a:noFill/>
-          <a:ln w="12700">
-            <a:solidFill>
-              <a:prstClr val="black"/>
-            </a:solidFill>
-          </a:ln>
-        </p:spPr>
-        <p:txBody>
-          <a:bodyPr vert="horz" lIns="91440" tIns="45720" rIns="91440" bIns="45720" rtlCol="0" anchor="ctr"/>
-          <a:lstStyle/>
-          <a:p>
-            <a:endParaRPr lang="en-US"/>
-          </a:p>
-        </p:txBody>
-      </p:sp>
-      <p:sp>
-        <p:nvSpPr>
-          <p:cNvPr id="5" name="Notes Placeholder 4"/>
-          <p:cNvSpPr>
-            <a:spLocks noGrp="1"/>
-          </p:cNvSpPr>
-          <p:nvPr>
-            <p:ph type="body" sz="quarter" idx="3"/>
-          </p:nvPr>
-        </p:nvSpPr>
-        <p:spPr>
-          <a:xfrm>
-            <a:off x="685800" y="4400550"/>
-            <a:ext cx="5486400" cy="3600450"/>
-          </a:xfrm>
-          <a:prstGeom prst="rect">
-            <a:avLst/>
-          </a:prstGeom>
-        </p:spPr>
-        <p:txBody>
-          <a:bodyPr vert="horz" lIns="91440" tIns="45720" rIns="91440" bIns="45720" rtlCol="0"/>
-          <a:lstStyle/>
-          <a:p>
-            <a:pPr lvl="0"/>
-            <a:r>
-              <a:rPr lang="en-US"/>
-              <a:t>Click to edit Master text styles</a:t>
-            </a:r>
-          </a:p>
-          <a:p>
-            <a:pPr lvl="1"/>
-            <a:r>
-              <a:rPr lang="en-US"/>
-              <a:t>Second level</a:t>
-            </a:r>
-          </a:p>
-          <a:p>
-            <a:pPr lvl="2"/>
-            <a:r>
-              <a:rPr lang="en-US"/>
-              <a:t>Third level</a:t>
-            </a:r>
-          </a:p>
-          <a:p>
-            <a:pPr lvl="3"/>
-            <a:r>
-              <a:rPr lang="en-US"/>
-              <a:t>Fourth level</a:t>
-            </a:r>
-          </a:p>
-          <a:p>
-            <a:pPr lvl="4"/>
-            <a:r>
-              <a:rPr lang="en-US"/>
-              <a:t>Fifth level</a:t>
-            </a:r>
-          </a:p>
-        </p:txBody>
-      </p:sp>
-      <p:sp>
-        <p:nvSpPr>
-          <p:cNvPr id="6" name="Footer Placeholder 5"/>
-          <p:cNvSpPr>
-            <a:spLocks noGrp="1"/>
-          </p:cNvSpPr>
-          <p:nvPr>
-            <p:ph type="ftr" sz="quarter" idx="4"/>
-          </p:nvPr>
-        </p:nvSpPr>
-        <p:spPr>
-          <a:xfrm>
-            <a:off x="0" y="8685213"/>
-            <a:ext cx="2971800" cy="458787"/>
-          </a:xfrm>
-          <a:prstGeom prst="rect">
-            <a:avLst/>
-          </a:prstGeom>
-        </p:spPr>
-        <p:txBody>
-          <a:bodyPr vert="horz" lIns="91440" tIns="45720" rIns="91440" bIns="45720" rtlCol="0" anchor="b"/>
-          <a:lstStyle>
-            <a:lvl1pPr algn="l">
-              <a:defRPr sz="1200"/>
-            </a:lvl1pPr>
-          </a:lstStyle>
-          <a:p>
-            <a:endParaRPr lang="en-US"/>
-          </a:p>
-        </p:txBody>
-      </p:sp>
-      <p:sp>
-        <p:nvSpPr>
-          <p:cNvPr id="7" name="Slide Number Placeholder 6"/>
-          <p:cNvSpPr>
-            <a:spLocks noGrp="1"/>
-          </p:cNvSpPr>
-          <p:nvPr>
-            <p:ph type="sldNum" sz="quarter" idx="5"/>
-          </p:nvPr>
-        </p:nvSpPr>
-        <p:spPr>
-          <a:xfrm>
-            <a:off x="3884613" y="8685213"/>
-            <a:ext cx="2971800" cy="458787"/>
-          </a:xfrm>
-          <a:prstGeom prst="rect">
-            <a:avLst/>
-          </a:prstGeom>
-        </p:spPr>
-        <p:txBody>
-          <a:bodyPr vert="horz" lIns="91440" tIns="45720" rIns="91440" bIns="45720" rtlCol="0" anchor="b"/>
-          <a:lstStyle>
-            <a:lvl1pPr algn="r">
-              <a:defRPr sz="1200"/>
-            </a:lvl1pPr>
-          </a:lstStyle>
-          <a:p>
-            <a:fld id="{CE5E9CC1-C706-0F49-92D6-E571CC5EEA8F}" type="slidenum">
-              <a:rPr lang="en-US"/>
-              <a:t>‹#›</a:t>
-            </a:fld>
-            <a:endParaRPr lang="en-US"/>
-          </a:p>
-        </p:txBody>
-      </p:sp>
     </p:spTree>
     <p:extLst>
       <p:ext uri="{BB962C8B-B14F-4D97-AF65-F5344CB8AC3E}">
-        <p14:creationId xmlns:p14="http://schemas.microsoft.com/office/powerpoint/2010/main" val="1024086991"/>
+        <p14:creationId xmlns:p14="http://schemas.microsoft.com/office/powerpoint/2010/main" val="1480438123"/>
       </p:ext>
     </p:extLst>
   </p:cSld>
@@ -513,7 +294,6 @@
               <a:rPr lang="en-US" dirty="0"/>
               <a:t>Hello everyone, we are presenting Dukaan Saathi—an intelligent AI business partner built specifically for traditional Kirana stores and local shops to digitize their business with zero friction.</a:t>
             </a:r>
-            <a:endParaRPr lang="en-US" dirty="0"/>
           </a:p>
         </p:txBody>
       </p:sp>
@@ -601,7 +381,6 @@
               <a:rPr lang="en-US" dirty="0"/>
               <a:t>Thank you for your time. Dukaan Saathi is live right now—feel free to scan the QR code to try it yourself, and we'd be happy to show you a live demo and answer any questions.</a:t>
             </a:r>
-            <a:endParaRPr lang="en-US" dirty="0"/>
           </a:p>
         </p:txBody>
       </p:sp>
@@ -689,7 +468,6 @@
               <a:rPr lang="en-US" dirty="0"/>
               <a:t>Today, millions of Kirana stores still run on physical notebooks. Tracking daily sales, managing credit (Udhaar), and knowing what's out of stock is a massive headache. Existing software solutions are built for supermarkets, not for small shopkeepers, because the learning curve is too steep.</a:t>
             </a:r>
-            <a:endParaRPr lang="en-US" dirty="0"/>
           </a:p>
         </p:txBody>
       </p:sp>
@@ -777,7 +555,6 @@
               <a:rPr lang="en-US" dirty="0"/>
               <a:t>Our solution is Dukaan Saathi. It’s an intuitive, voice-first dashboard that requires zero technical skills to use. It speaks the shopkeeper's language—literally—with full support for regional languages so anyone can use it immediately.</a:t>
             </a:r>
-            <a:endParaRPr lang="en-US" dirty="0"/>
           </a:p>
         </p:txBody>
       </p:sp>
@@ -865,7 +642,6 @@
               <a:rPr lang="en-US" dirty="0"/>
               <a:t>The core of our app is the AI Assistant. A shopkeeper doesn't have time to navigate complex menus while dealing with a line of customers. With Dukaan Saathi, they just tap the microphone and say 'I sold 2 kilos of sugar to Ramesh for 100 rupees', and our AI automatically parses the natural language and logs the sale and updates the inventory.</a:t>
             </a:r>
-            <a:endParaRPr lang="en-US" dirty="0"/>
           </a:p>
         </p:txBody>
       </p:sp>
@@ -953,7 +729,6 @@
               <a:rPr lang="en-US" dirty="0"/>
               <a:t>All those voice inputs feed directly into a real-time smart dashboard. For the first time, a small shop owner can see their daily revenue, top-selling items, and overall growth at a glance, helping them make better business decisions.</a:t>
             </a:r>
-            <a:endParaRPr lang="en-US" dirty="0"/>
           </a:p>
         </p:txBody>
       </p:sp>
@@ -1041,7 +816,6 @@
               <a:rPr lang="en-US" dirty="0"/>
               <a:t>Credit, or Udhaar, is the backbone of local Indian commerce. We built a dedicated Udhaar tracker that automatically creates customer profiles when the AI detects an unpaid sale, ensuring no money is ever lost to lost notebooks.</a:t>
             </a:r>
-            <a:endParaRPr lang="en-US" dirty="0"/>
           </a:p>
         </p:txBody>
       </p:sp>
@@ -1129,7 +903,6 @@
               <a:rPr lang="en-US" dirty="0"/>
               <a:t>We believe utility shouldn't mean ugly. We engineered a premium, lightning-fast UI with dynamic Dark Mode support and responsive design, ensuring it looks and works perfectly whether the shopkeeper is using a cheap Android phone or a desktop computer.</a:t>
             </a:r>
-            <a:endParaRPr lang="en-US" dirty="0"/>
           </a:p>
         </p:txBody>
       </p:sp>
@@ -1217,7 +990,6 @@
               <a:rPr lang="en-US" dirty="0"/>
               <a:t>Under the hood, Dukaan Saathi is powered by a modern Vite/React frontend styled with Tailwind CSS for rapid, responsive UI development. The backend runs on Express and Node.js, utilizing SQLite to keep data lightweight and easily deployable.</a:t>
             </a:r>
-            <a:endParaRPr lang="en-US" dirty="0"/>
           </a:p>
         </p:txBody>
       </p:sp>
@@ -1305,7 +1077,6 @@
               <a:rPr lang="en-US" dirty="0"/>
               <a:t>For our next steps, we plan to integrate WhatsApp APIs so receipts can be sent instantly to customers. We also plan to wrap this PWA into a native Android application, and introduce predictive AI that tells the shopkeeper exactly what to restock before they run out.</a:t>
             </a:r>
-            <a:endParaRPr lang="en-US" dirty="0"/>
           </a:p>
         </p:txBody>
       </p:sp>
@@ -1383,6 +1154,7 @@
         <a:solidFill>
           <a:srgbClr val="FFFFFF"/>
         </a:solidFill>
+        <a:effectLst/>
       </p:bgPr>
     </p:bg>
     <p:spTree>
@@ -1420,7 +1192,7 @@
           <a:bodyPr wrap="square" rtlCol="0" anchor="ctr"/>
           <a:lstStyle/>
           <a:p>
-            <a:pPr indent="0" marL="0">
+            <a:pPr marL="0" indent="0">
               <a:buNone/>
             </a:pPr>
             <a:r>
@@ -1446,6 +1218,11 @@
 <file path=ppt/slideMasters/slideMaster1.xml><?xml version="1.0" encoding="utf-8"?>
 <p:sldMaster xmlns:a="http://schemas.openxmlformats.org/drawingml/2006/main" xmlns:r="http://schemas.openxmlformats.org/officeDocument/2006/relationships" xmlns:p="http://schemas.openxmlformats.org/presentationml/2006/main">
   <p:cSld>
+    <p:bg>
+      <p:bgRef idx="1001">
+        <a:schemeClr val="bg1"/>
+      </p:bgRef>
+    </p:bg>
     <p:spTree>
       <p:nvGrpSpPr>
         <p:cNvPr id="1" name=""/>
@@ -1746,7 +1523,7 @@
         </p:nvSpPr>
         <p:spPr>
           <a:xfrm>
-            <a:off x="914400" y="1543050"/>
+            <a:off x="406400" y="110490"/>
             <a:ext cx="7315200" cy="914400"/>
           </a:xfrm>
           <a:prstGeom prst="rect">
@@ -1759,7 +1536,7 @@
           <a:bodyPr wrap="square" rtlCol="0" anchor="ctr"/>
           <a:lstStyle/>
           <a:p>
-            <a:pPr algn="ctr" indent="0" marL="0">
+            <a:pPr marL="0" indent="0" algn="ctr">
               <a:buNone/>
             </a:pPr>
             <a:r>
@@ -1782,7 +1559,7 @@
         </p:nvSpPr>
         <p:spPr>
           <a:xfrm>
-            <a:off x="914400" y="2314575"/>
+            <a:off x="467360" y="861695"/>
             <a:ext cx="7315200" cy="457200"/>
           </a:xfrm>
           <a:prstGeom prst="rect">
@@ -1795,7 +1572,7 @@
           <a:bodyPr wrap="square" rtlCol="0" anchor="ctr"/>
           <a:lstStyle/>
           <a:p>
-            <a:pPr algn="ctr" indent="0" marL="0">
+            <a:pPr marL="0" indent="0" algn="ctr">
               <a:buNone/>
             </a:pPr>
             <a:r>
@@ -1818,7 +1595,7 @@
         </p:nvSpPr>
         <p:spPr>
           <a:xfrm>
-            <a:off x="914400" y="3086100"/>
+            <a:off x="335280" y="1379220"/>
             <a:ext cx="7315200" cy="457200"/>
           </a:xfrm>
           <a:prstGeom prst="rect">
@@ -1831,7 +1608,7 @@
           <a:bodyPr wrap="square" rtlCol="0" anchor="ctr"/>
           <a:lstStyle/>
           <a:p>
-            <a:pPr algn="ctr" indent="0" marL="0">
+            <a:pPr marL="0" indent="0" algn="ctr">
               <a:buNone/>
             </a:pPr>
             <a:r>
@@ -1840,12 +1617,42 @@
                   <a:srgbClr val="64748B"/>
                 </a:solidFill>
               </a:rPr>
-              <a:t>Team Name: [Your Team Name]</a:t>
+              <a:t>Team Name: [Zero Friction]</a:t>
             </a:r>
             <a:endParaRPr lang="en-US" sz="2000" dirty="0"/>
           </a:p>
         </p:txBody>
       </p:sp>
+      <p:pic>
+        <p:nvPicPr>
+          <p:cNvPr id="6" name="Picture 5">
+            <a:extLst>
+              <a:ext uri="{FF2B5EF4-FFF2-40B4-BE49-F238E27FC236}">
+                <a16:creationId xmlns:a16="http://schemas.microsoft.com/office/drawing/2014/main" id="{B8D6138D-A98A-949C-90F0-7ACD88A1FC4C}"/>
+              </a:ext>
+            </a:extLst>
+          </p:cNvPr>
+          <p:cNvPicPr>
+            <a:picLocks noChangeAspect="1"/>
+          </p:cNvPicPr>
+          <p:nvPr/>
+        </p:nvPicPr>
+        <p:blipFill>
+          <a:blip r:embed="rId3"/>
+          <a:stretch>
+            <a:fillRect/>
+          </a:stretch>
+        </p:blipFill>
+        <p:spPr>
+          <a:xfrm>
+            <a:off x="721360" y="1776095"/>
+            <a:ext cx="7579360" cy="3256915"/>
+          </a:xfrm>
+          <a:prstGeom prst="rect">
+            <a:avLst/>
+          </a:prstGeom>
+        </p:spPr>
+      </p:pic>
     </p:spTree>
   </p:cSld>
   <p:clrMapOvr>
@@ -1879,8 +1686,8 @@
         </p:nvSpPr>
         <p:spPr>
           <a:xfrm>
-            <a:off x="914400" y="1543050"/>
-            <a:ext cx="7315200" cy="914400"/>
+            <a:off x="721360" y="1278890"/>
+            <a:ext cx="7315200" cy="1109980"/>
           </a:xfrm>
           <a:prstGeom prst="rect">
             <a:avLst/>
@@ -1892,7 +1699,7 @@
           <a:bodyPr wrap="square" rtlCol="0" anchor="ctr"/>
           <a:lstStyle/>
           <a:p>
-            <a:pPr algn="ctr" indent="0" marL="0">
+            <a:pPr marL="0" indent="0" algn="ctr">
               <a:buNone/>
             </a:pPr>
             <a:r>
@@ -1915,7 +1722,7 @@
         </p:nvSpPr>
         <p:spPr>
           <a:xfrm>
-            <a:off x="914400" y="2571750"/>
+            <a:off x="914400" y="2632710"/>
             <a:ext cx="7315200" cy="457200"/>
           </a:xfrm>
           <a:prstGeom prst="rect">
@@ -1928,7 +1735,7 @@
           <a:bodyPr wrap="square" rtlCol="0" anchor="ctr"/>
           <a:lstStyle/>
           <a:p>
-            <a:pPr algn="ctr" indent="0" marL="0">
+            <a:pPr marL="0" indent="0" algn="ctr">
               <a:buNone/>
             </a:pPr>
             <a:r>
@@ -1940,6 +1747,41 @@
               <a:t>Try it live: https://dukaan-saathi-new.onrender.com/onboarding</a:t>
             </a:r>
             <a:endParaRPr lang="en-US" sz="2400" dirty="0"/>
+          </a:p>
+        </p:txBody>
+      </p:sp>
+      <p:sp>
+        <p:nvSpPr>
+          <p:cNvPr id="5" name="TextBox 4">
+            <a:extLst>
+              <a:ext uri="{FF2B5EF4-FFF2-40B4-BE49-F238E27FC236}">
+                <a16:creationId xmlns:a16="http://schemas.microsoft.com/office/drawing/2014/main" id="{5CA5B06C-1972-5180-824A-B1233152A925}"/>
+              </a:ext>
+            </a:extLst>
+          </p:cNvPr>
+          <p:cNvSpPr txBox="1"/>
+          <p:nvPr/>
+        </p:nvSpPr>
+        <p:spPr>
+          <a:xfrm>
+            <a:off x="3108960" y="3460656"/>
+            <a:ext cx="4164039" cy="369332"/>
+          </a:xfrm>
+          <a:prstGeom prst="rect">
+            <a:avLst/>
+          </a:prstGeom>
+          <a:noFill/>
+        </p:spPr>
+        <p:txBody>
+          <a:bodyPr wrap="square">
+            <a:spAutoFit/>
+          </a:bodyPr>
+          <a:lstStyle/>
+          <a:p>
+            <a:r>
+              <a:rPr lang="en-IN" dirty="0"/>
+              <a:t>~ TEAM ZERO FRICTION </a:t>
+            </a:r>
           </a:p>
         </p:txBody>
       </p:sp>
@@ -1989,7 +1831,7 @@
           <a:bodyPr wrap="square" rtlCol="0" anchor="ctr"/>
           <a:lstStyle/>
           <a:p>
-            <a:pPr indent="0" marL="0">
+            <a:pPr marL="0" indent="0">
               <a:buNone/>
             </a:pPr>
             <a:r>
@@ -2012,7 +1854,7 @@
         </p:nvSpPr>
         <p:spPr>
           <a:xfrm>
-            <a:off x="457200" y="1371600"/>
+            <a:off x="457200" y="1381760"/>
             <a:ext cx="8229600" cy="457200"/>
           </a:xfrm>
           <a:prstGeom prst="rect">
@@ -2025,7 +1867,7 @@
           <a:bodyPr wrap="square" rtlCol="0" anchor="ctr"/>
           <a:lstStyle/>
           <a:p>
-            <a:pPr indent="0" marL="0">
+            <a:pPr marL="0" indent="0">
               <a:buNone/>
             </a:pPr>
             <a:r>
@@ -2048,8 +1890,8 @@
         </p:nvSpPr>
         <p:spPr>
           <a:xfrm>
-            <a:off x="457200" y="2011680"/>
-            <a:ext cx="5029200" cy="3657600"/>
+            <a:off x="386080" y="1259840"/>
+            <a:ext cx="5029200" cy="3769360"/>
           </a:xfrm>
           <a:prstGeom prst="rect">
             <a:avLst/>
@@ -2074,115 +1916,70 @@
                   <a:srgbClr val="333333"/>
                 </a:solidFill>
               </a:rPr>
-              <a:t>Traditional shops rely on pen and paper.</a:t>
-            </a:r>
-            <a:pPr indent="0" marL="0">
-              <a:lnSpc>
-                <a:spcPts val="3500"/>
-              </a:lnSpc>
+              <a:t>Traditional shops rely on pen and paper.Udhaar (Credit) tracking is messy and error-prone.No analytics or real-time inventory tracking.Existing software is too complex for rural shop owners.</a:t>
+            </a:r>
+            <a:endParaRPr lang="en-US" sz="2000" dirty="0"/>
+          </a:p>
+        </p:txBody>
+      </p:sp>
+      <p:sp>
+        <p:nvSpPr>
+          <p:cNvPr id="7" name="Text 4"/>
+          <p:cNvSpPr/>
+          <p:nvPr/>
+        </p:nvSpPr>
+        <p:spPr>
+          <a:xfrm>
+            <a:off x="5943600" y="1828800"/>
+            <a:ext cx="5486400" cy="3657600"/>
+          </a:xfrm>
+          <a:prstGeom prst="rect">
+            <a:avLst/>
+          </a:prstGeom>
+          <a:noFill/>
+          <a:ln/>
+        </p:spPr>
+        <p:txBody>
+          <a:bodyPr wrap="square" rtlCol="0" anchor="ctr"/>
+          <a:lstStyle/>
+          <a:p>
+            <a:pPr marL="0" indent="0" algn="ctr">
               <a:buNone/>
             </a:pPr>
-            <a:r>
-              <a:rPr lang="en-US" sz="2000" dirty="0">
-                <a:solidFill>
-                  <a:srgbClr val="333333"/>
-                </a:solidFill>
-              </a:rPr>
-              <a:t>Udhaar (Credit) tracking is messy and error-prone.</a:t>
-            </a:r>
-            <a:pPr indent="0" marL="0">
-              <a:lnSpc>
-                <a:spcPts val="3500"/>
-              </a:lnSpc>
-              <a:buNone/>
-            </a:pPr>
-            <a:r>
-              <a:rPr lang="en-US" sz="2000" dirty="0">
-                <a:solidFill>
-                  <a:srgbClr val="333333"/>
-                </a:solidFill>
-              </a:rPr>
-              <a:t>No analytics or real-time inventory tracking.</a:t>
-            </a:r>
-            <a:pPr indent="0" marL="0">
-              <a:lnSpc>
-                <a:spcPts val="3500"/>
-              </a:lnSpc>
-              <a:buNone/>
-            </a:pPr>
-            <a:r>
-              <a:rPr lang="en-US" sz="2000" dirty="0">
-                <a:solidFill>
-                  <a:srgbClr val="333333"/>
-                </a:solidFill>
-              </a:rPr>
-              <a:t>Existing software is too complex for rural shop owners.</a:t>
-            </a:r>
-            <a:endParaRPr lang="en-US" sz="2000" dirty="0"/>
-          </a:p>
-        </p:txBody>
-      </p:sp>
-      <p:sp>
-        <p:nvSpPr>
-          <p:cNvPr id="6" name="Shape 3"/>
-          <p:cNvSpPr/>
-          <p:nvPr/>
-        </p:nvSpPr>
-        <p:spPr>
-          <a:xfrm>
-            <a:off x="5943600" y="1828800"/>
-            <a:ext cx="5486400" cy="3657600"/>
-          </a:xfrm>
-          <a:prstGeom prst="rect">
-            <a:avLst/>
-          </a:prstGeom>
-          <a:solidFill>
-            <a:srgbClr val="E2E8F0"/>
-          </a:solidFill>
-          <a:ln w="25400">
-            <a:solidFill>
-              <a:srgbClr val="CBD5E1"/>
-            </a:solidFill>
-            <a:prstDash val="solid"/>
-          </a:ln>
-        </p:spPr>
-      </p:sp>
-      <p:sp>
-        <p:nvSpPr>
-          <p:cNvPr id="7" name="Text 4"/>
-          <p:cNvSpPr/>
-          <p:nvPr/>
-        </p:nvSpPr>
-        <p:spPr>
-          <a:xfrm>
-            <a:off x="5943600" y="1828800"/>
-            <a:ext cx="5486400" cy="3657600"/>
-          </a:xfrm>
-          <a:prstGeom prst="rect">
-            <a:avLst/>
-          </a:prstGeom>
-          <a:noFill/>
-          <a:ln/>
-        </p:spPr>
-        <p:txBody>
-          <a:bodyPr wrap="square" rtlCol="0" anchor="ctr"/>
-          <a:lstStyle/>
-          <a:p>
-            <a:pPr algn="ctr" indent="0" marL="0">
-              <a:buNone/>
-            </a:pPr>
-            <a:r>
-              <a:rPr lang="en-US" sz="1800" b="1" dirty="0">
-                <a:solidFill>
-                  <a:srgbClr val="94A3B8"/>
-                </a:solidFill>
-              </a:rPr>
-              <a:t>Paste Screenshot Here</a:t>
-            </a:r>
             <a:endParaRPr lang="en-US" sz="1800" dirty="0"/>
           </a:p>
         </p:txBody>
       </p:sp>
+      <p:pic>
+        <p:nvPicPr>
+          <p:cNvPr id="8" name="Picture 7">
+            <a:extLst>
+              <a:ext uri="{FF2B5EF4-FFF2-40B4-BE49-F238E27FC236}">
+                <a16:creationId xmlns:a16="http://schemas.microsoft.com/office/drawing/2014/main" id="{6D438120-6AE0-9DEE-2097-DC4388C67E74}"/>
+              </a:ext>
+            </a:extLst>
+          </p:cNvPr>
+          <p:cNvPicPr>
+            <a:picLocks noChangeAspect="1"/>
+          </p:cNvPicPr>
+          <p:nvPr/>
+        </p:nvPicPr>
+        <p:blipFill>
+          <a:blip r:embed="rId3"/>
+          <a:stretch>
+            <a:fillRect/>
+          </a:stretch>
+        </p:blipFill>
+        <p:spPr>
+          <a:xfrm>
+            <a:off x="5486400" y="1172464"/>
+            <a:ext cx="3423920" cy="3423920"/>
+          </a:xfrm>
+          <a:prstGeom prst="rect">
+            <a:avLst/>
+          </a:prstGeom>
+        </p:spPr>
+      </p:pic>
     </p:spTree>
   </p:cSld>
   <p:clrMapOvr>
@@ -2229,7 +2026,7 @@
           <a:bodyPr wrap="square" rtlCol="0" anchor="ctr"/>
           <a:lstStyle/>
           <a:p>
-            <a:pPr indent="0" marL="0">
+            <a:pPr marL="0" indent="0">
               <a:buNone/>
             </a:pPr>
             <a:r>
@@ -2252,8 +2049,8 @@
         </p:nvSpPr>
         <p:spPr>
           <a:xfrm>
-            <a:off x="457200" y="1371600"/>
-            <a:ext cx="8229600" cy="457200"/>
+            <a:off x="355600" y="2235200"/>
+            <a:ext cx="8229600" cy="528320"/>
           </a:xfrm>
           <a:prstGeom prst="rect">
             <a:avLst/>
@@ -2265,7 +2062,7 @@
           <a:bodyPr wrap="square" rtlCol="0" anchor="ctr"/>
           <a:lstStyle/>
           <a:p>
-            <a:pPr indent="0" marL="0">
+            <a:pPr marL="0" indent="0">
               <a:buNone/>
             </a:pPr>
             <a:r>
@@ -2288,8 +2085,8 @@
         </p:nvSpPr>
         <p:spPr>
           <a:xfrm>
-            <a:off x="457200" y="2011680"/>
-            <a:ext cx="5029200" cy="3657600"/>
+            <a:off x="142240" y="2082800"/>
+            <a:ext cx="5110480" cy="3657600"/>
           </a:xfrm>
           <a:prstGeom prst="rect">
             <a:avLst/>
@@ -2314,115 +2111,70 @@
                   <a:srgbClr val="333333"/>
                 </a:solidFill>
               </a:rPr>
-              <a:t>Zero Learning Curve</a:t>
-            </a:r>
-            <a:pPr indent="0" marL="0">
-              <a:lnSpc>
-                <a:spcPts val="3500"/>
-              </a:lnSpc>
+              <a:t>Zero Learning CurveVoice-First AI LoggingMultilingual Support (English, Hindi, Telugu)Designed for Mobile &amp; Desktop</a:t>
+            </a:r>
+            <a:endParaRPr lang="en-US" sz="2000" dirty="0"/>
+          </a:p>
+        </p:txBody>
+      </p:sp>
+      <p:sp>
+        <p:nvSpPr>
+          <p:cNvPr id="7" name="Text 4"/>
+          <p:cNvSpPr/>
+          <p:nvPr/>
+        </p:nvSpPr>
+        <p:spPr>
+          <a:xfrm>
+            <a:off x="5943600" y="1828800"/>
+            <a:ext cx="5486400" cy="3657600"/>
+          </a:xfrm>
+          <a:prstGeom prst="rect">
+            <a:avLst/>
+          </a:prstGeom>
+          <a:noFill/>
+          <a:ln/>
+        </p:spPr>
+        <p:txBody>
+          <a:bodyPr wrap="square" rtlCol="0" anchor="ctr"/>
+          <a:lstStyle/>
+          <a:p>
+            <a:pPr marL="0" indent="0" algn="ctr">
               <a:buNone/>
             </a:pPr>
-            <a:r>
-              <a:rPr lang="en-US" sz="2000" dirty="0">
-                <a:solidFill>
-                  <a:srgbClr val="333333"/>
-                </a:solidFill>
-              </a:rPr>
-              <a:t>Voice-First AI Logging</a:t>
-            </a:r>
-            <a:pPr indent="0" marL="0">
-              <a:lnSpc>
-                <a:spcPts val="3500"/>
-              </a:lnSpc>
-              <a:buNone/>
-            </a:pPr>
-            <a:r>
-              <a:rPr lang="en-US" sz="2000" dirty="0">
-                <a:solidFill>
-                  <a:srgbClr val="333333"/>
-                </a:solidFill>
-              </a:rPr>
-              <a:t>Multilingual Support (English, Hindi, Telugu)</a:t>
-            </a:r>
-            <a:pPr indent="0" marL="0">
-              <a:lnSpc>
-                <a:spcPts val="3500"/>
-              </a:lnSpc>
-              <a:buNone/>
-            </a:pPr>
-            <a:r>
-              <a:rPr lang="en-US" sz="2000" dirty="0">
-                <a:solidFill>
-                  <a:srgbClr val="333333"/>
-                </a:solidFill>
-              </a:rPr>
-              <a:t>Designed for Mobile &amp; Desktop</a:t>
-            </a:r>
-            <a:endParaRPr lang="en-US" sz="2000" dirty="0"/>
-          </a:p>
-        </p:txBody>
-      </p:sp>
-      <p:sp>
-        <p:nvSpPr>
-          <p:cNvPr id="6" name="Shape 3"/>
-          <p:cNvSpPr/>
-          <p:nvPr/>
-        </p:nvSpPr>
-        <p:spPr>
-          <a:xfrm>
-            <a:off x="5943600" y="1828800"/>
-            <a:ext cx="5486400" cy="3657600"/>
-          </a:xfrm>
-          <a:prstGeom prst="rect">
-            <a:avLst/>
-          </a:prstGeom>
-          <a:solidFill>
-            <a:srgbClr val="E2E8F0"/>
-          </a:solidFill>
-          <a:ln w="25400">
-            <a:solidFill>
-              <a:srgbClr val="CBD5E1"/>
-            </a:solidFill>
-            <a:prstDash val="solid"/>
-          </a:ln>
-        </p:spPr>
-      </p:sp>
-      <p:sp>
-        <p:nvSpPr>
-          <p:cNvPr id="7" name="Text 4"/>
-          <p:cNvSpPr/>
-          <p:nvPr/>
-        </p:nvSpPr>
-        <p:spPr>
-          <a:xfrm>
-            <a:off x="5943600" y="1828800"/>
-            <a:ext cx="5486400" cy="3657600"/>
-          </a:xfrm>
-          <a:prstGeom prst="rect">
-            <a:avLst/>
-          </a:prstGeom>
-          <a:noFill/>
-          <a:ln/>
-        </p:spPr>
-        <p:txBody>
-          <a:bodyPr wrap="square" rtlCol="0" anchor="ctr"/>
-          <a:lstStyle/>
-          <a:p>
-            <a:pPr algn="ctr" indent="0" marL="0">
-              <a:buNone/>
-            </a:pPr>
-            <a:r>
-              <a:rPr lang="en-US" sz="1800" b="1" dirty="0">
-                <a:solidFill>
-                  <a:srgbClr val="94A3B8"/>
-                </a:solidFill>
-              </a:rPr>
-              <a:t>Paste Screenshot Here</a:t>
-            </a:r>
             <a:endParaRPr lang="en-US" sz="1800" dirty="0"/>
           </a:p>
         </p:txBody>
       </p:sp>
+      <p:pic>
+        <p:nvPicPr>
+          <p:cNvPr id="10" name="Picture 9">
+            <a:extLst>
+              <a:ext uri="{FF2B5EF4-FFF2-40B4-BE49-F238E27FC236}">
+                <a16:creationId xmlns:a16="http://schemas.microsoft.com/office/drawing/2014/main" id="{8ABC9DE2-BE24-025C-F293-B592022597E4}"/>
+              </a:ext>
+            </a:extLst>
+          </p:cNvPr>
+          <p:cNvPicPr>
+            <a:picLocks noChangeAspect="1"/>
+          </p:cNvPicPr>
+          <p:nvPr/>
+        </p:nvPicPr>
+        <p:blipFill>
+          <a:blip r:embed="rId3"/>
+          <a:stretch>
+            <a:fillRect/>
+          </a:stretch>
+        </p:blipFill>
+        <p:spPr>
+          <a:xfrm>
+            <a:off x="3200401" y="289422"/>
+            <a:ext cx="5862319" cy="2931298"/>
+          </a:xfrm>
+          <a:prstGeom prst="rect">
+            <a:avLst/>
+          </a:prstGeom>
+        </p:spPr>
+      </p:pic>
     </p:spTree>
   </p:cSld>
   <p:clrMapOvr>
@@ -2469,7 +2221,7 @@
           <a:bodyPr wrap="square" rtlCol="0" anchor="ctr"/>
           <a:lstStyle/>
           <a:p>
-            <a:pPr indent="0" marL="0">
+            <a:pPr marL="0" indent="0">
               <a:buNone/>
             </a:pPr>
             <a:r>
@@ -2492,8 +2244,8 @@
         </p:nvSpPr>
         <p:spPr>
           <a:xfrm>
-            <a:off x="457200" y="1371600"/>
-            <a:ext cx="8229600" cy="457200"/>
+            <a:off x="772160" y="2309544"/>
+            <a:ext cx="8229600" cy="707976"/>
           </a:xfrm>
           <a:prstGeom prst="rect">
             <a:avLst/>
@@ -2505,7 +2257,7 @@
           <a:bodyPr wrap="square" rtlCol="0" anchor="ctr"/>
           <a:lstStyle/>
           <a:p>
-            <a:pPr indent="0" marL="0">
+            <a:pPr marL="0" indent="0">
               <a:buNone/>
             </a:pPr>
             <a:r>
@@ -2554,101 +2306,70 @@
                   <a:srgbClr val="333333"/>
                 </a:solidFill>
               </a:rPr>
-              <a:t>Log sales naturally via voice.</a:t>
-            </a:r>
-            <a:pPr indent="0" marL="0">
-              <a:lnSpc>
-                <a:spcPts val="3500"/>
-              </a:lnSpc>
+              <a:t>Log sales naturally via voice.NLP Parsing automatically extracts items, prices, and names.Updates inventory instantly.</a:t>
+            </a:r>
+            <a:endParaRPr lang="en-US" sz="2000" dirty="0"/>
+          </a:p>
+        </p:txBody>
+      </p:sp>
+      <p:sp>
+        <p:nvSpPr>
+          <p:cNvPr id="7" name="Text 4"/>
+          <p:cNvSpPr/>
+          <p:nvPr/>
+        </p:nvSpPr>
+        <p:spPr>
+          <a:xfrm>
+            <a:off x="5943600" y="1828800"/>
+            <a:ext cx="5486400" cy="3657600"/>
+          </a:xfrm>
+          <a:prstGeom prst="rect">
+            <a:avLst/>
+          </a:prstGeom>
+          <a:noFill/>
+          <a:ln/>
+        </p:spPr>
+        <p:txBody>
+          <a:bodyPr wrap="square" rtlCol="0" anchor="ctr"/>
+          <a:lstStyle/>
+          <a:p>
+            <a:pPr marL="0" indent="0" algn="ctr">
               <a:buNone/>
             </a:pPr>
-            <a:r>
-              <a:rPr lang="en-US" sz="2000" dirty="0">
-                <a:solidFill>
-                  <a:srgbClr val="333333"/>
-                </a:solidFill>
-              </a:rPr>
-              <a:t>NLP Parsing automatically extracts items, prices, and names.</a:t>
-            </a:r>
-            <a:pPr indent="0" marL="0">
-              <a:lnSpc>
-                <a:spcPts val="3500"/>
-              </a:lnSpc>
-              <a:buNone/>
-            </a:pPr>
-            <a:r>
-              <a:rPr lang="en-US" sz="2000" dirty="0">
-                <a:solidFill>
-                  <a:srgbClr val="333333"/>
-                </a:solidFill>
-              </a:rPr>
-              <a:t>Updates inventory instantly.</a:t>
-            </a:r>
-            <a:endParaRPr lang="en-US" sz="2000" dirty="0"/>
-          </a:p>
-        </p:txBody>
-      </p:sp>
-      <p:sp>
-        <p:nvSpPr>
-          <p:cNvPr id="6" name="Shape 3"/>
-          <p:cNvSpPr/>
-          <p:nvPr/>
-        </p:nvSpPr>
-        <p:spPr>
-          <a:xfrm>
-            <a:off x="5943600" y="1828800"/>
-            <a:ext cx="5486400" cy="3657600"/>
-          </a:xfrm>
-          <a:prstGeom prst="rect">
-            <a:avLst/>
-          </a:prstGeom>
-          <a:solidFill>
-            <a:srgbClr val="E2E8F0"/>
-          </a:solidFill>
-          <a:ln w="25400">
-            <a:solidFill>
-              <a:srgbClr val="CBD5E1"/>
-            </a:solidFill>
-            <a:prstDash val="solid"/>
-          </a:ln>
-        </p:spPr>
-      </p:sp>
-      <p:sp>
-        <p:nvSpPr>
-          <p:cNvPr id="7" name="Text 4"/>
-          <p:cNvSpPr/>
-          <p:nvPr/>
-        </p:nvSpPr>
-        <p:spPr>
-          <a:xfrm>
-            <a:off x="5943600" y="1828800"/>
-            <a:ext cx="5486400" cy="3657600"/>
-          </a:xfrm>
-          <a:prstGeom prst="rect">
-            <a:avLst/>
-          </a:prstGeom>
-          <a:noFill/>
-          <a:ln/>
-        </p:spPr>
-        <p:txBody>
-          <a:bodyPr wrap="square" rtlCol="0" anchor="ctr"/>
-          <a:lstStyle/>
-          <a:p>
-            <a:pPr algn="ctr" indent="0" marL="0">
-              <a:buNone/>
-            </a:pPr>
-            <a:r>
-              <a:rPr lang="en-US" sz="1800" b="1" dirty="0">
-                <a:solidFill>
-                  <a:srgbClr val="94A3B8"/>
-                </a:solidFill>
-              </a:rPr>
-              <a:t>Paste Screenshot Here</a:t>
-            </a:r>
             <a:endParaRPr lang="en-US" sz="1800" dirty="0"/>
           </a:p>
         </p:txBody>
       </p:sp>
+      <p:pic>
+        <p:nvPicPr>
+          <p:cNvPr id="8" name="Picture 7">
+            <a:extLst>
+              <a:ext uri="{FF2B5EF4-FFF2-40B4-BE49-F238E27FC236}">
+                <a16:creationId xmlns:a16="http://schemas.microsoft.com/office/drawing/2014/main" id="{41350C89-7FA9-4079-E0C2-C4EFBE1AD297}"/>
+              </a:ext>
+            </a:extLst>
+          </p:cNvPr>
+          <p:cNvPicPr>
+            <a:picLocks noChangeAspect="1"/>
+          </p:cNvPicPr>
+          <p:nvPr/>
+        </p:nvPicPr>
+        <p:blipFill>
+          <a:blip r:embed="rId3"/>
+          <a:stretch>
+            <a:fillRect/>
+          </a:stretch>
+        </p:blipFill>
+        <p:spPr>
+          <a:xfrm>
+            <a:off x="3728720" y="1124536"/>
+            <a:ext cx="4958080" cy="2025064"/>
+          </a:xfrm>
+          <a:prstGeom prst="rect">
+            <a:avLst/>
+          </a:prstGeom>
+        </p:spPr>
+      </p:pic>
     </p:spTree>
   </p:cSld>
   <p:clrMapOvr>
@@ -2695,7 +2416,7 @@
           <a:bodyPr wrap="square" rtlCol="0" anchor="ctr"/>
           <a:lstStyle/>
           <a:p>
-            <a:pPr indent="0" marL="0">
+            <a:pPr marL="0" indent="0">
               <a:buNone/>
             </a:pPr>
             <a:r>
@@ -2718,8 +2439,8 @@
         </p:nvSpPr>
         <p:spPr>
           <a:xfrm>
-            <a:off x="457200" y="1371600"/>
-            <a:ext cx="8229600" cy="457200"/>
+            <a:off x="457200" y="2387600"/>
+            <a:ext cx="8229600" cy="558800"/>
           </a:xfrm>
           <a:prstGeom prst="rect">
             <a:avLst/>
@@ -2731,7 +2452,7 @@
           <a:bodyPr wrap="square" rtlCol="0" anchor="ctr"/>
           <a:lstStyle/>
           <a:p>
-            <a:pPr indent="0" marL="0">
+            <a:pPr marL="0" indent="0">
               <a:buNone/>
             </a:pPr>
             <a:r>
@@ -2780,101 +2501,70 @@
                   <a:srgbClr val="333333"/>
                 </a:solidFill>
               </a:rPr>
-              <a:t>Real-time Sales Analytics</a:t>
-            </a:r>
-            <a:pPr indent="0" marL="0">
-              <a:lnSpc>
-                <a:spcPts val="3500"/>
-              </a:lnSpc>
+              <a:t>Real-time Sales AnalyticsDaily &amp; Monthly Revenue TrackingBeautiful, intuitive UI for quick insights</a:t>
+            </a:r>
+            <a:endParaRPr lang="en-US" sz="2000" dirty="0"/>
+          </a:p>
+        </p:txBody>
+      </p:sp>
+      <p:sp>
+        <p:nvSpPr>
+          <p:cNvPr id="7" name="Text 4"/>
+          <p:cNvSpPr/>
+          <p:nvPr/>
+        </p:nvSpPr>
+        <p:spPr>
+          <a:xfrm>
+            <a:off x="5943600" y="1828800"/>
+            <a:ext cx="5486400" cy="3657600"/>
+          </a:xfrm>
+          <a:prstGeom prst="rect">
+            <a:avLst/>
+          </a:prstGeom>
+          <a:noFill/>
+          <a:ln/>
+        </p:spPr>
+        <p:txBody>
+          <a:bodyPr wrap="square" rtlCol="0" anchor="ctr"/>
+          <a:lstStyle/>
+          <a:p>
+            <a:pPr marL="0" indent="0" algn="ctr">
               <a:buNone/>
             </a:pPr>
-            <a:r>
-              <a:rPr lang="en-US" sz="2000" dirty="0">
-                <a:solidFill>
-                  <a:srgbClr val="333333"/>
-                </a:solidFill>
-              </a:rPr>
-              <a:t>Daily &amp; Monthly Revenue Tracking</a:t>
-            </a:r>
-            <a:pPr indent="0" marL="0">
-              <a:lnSpc>
-                <a:spcPts val="3500"/>
-              </a:lnSpc>
-              <a:buNone/>
-            </a:pPr>
-            <a:r>
-              <a:rPr lang="en-US" sz="2000" dirty="0">
-                <a:solidFill>
-                  <a:srgbClr val="333333"/>
-                </a:solidFill>
-              </a:rPr>
-              <a:t>Beautiful, intuitive UI for quick insights</a:t>
-            </a:r>
-            <a:endParaRPr lang="en-US" sz="2000" dirty="0"/>
-          </a:p>
-        </p:txBody>
-      </p:sp>
-      <p:sp>
-        <p:nvSpPr>
-          <p:cNvPr id="6" name="Shape 3"/>
-          <p:cNvSpPr/>
-          <p:nvPr/>
-        </p:nvSpPr>
-        <p:spPr>
-          <a:xfrm>
-            <a:off x="5943600" y="1828800"/>
-            <a:ext cx="5486400" cy="3657600"/>
-          </a:xfrm>
-          <a:prstGeom prst="rect">
-            <a:avLst/>
-          </a:prstGeom>
-          <a:solidFill>
-            <a:srgbClr val="E2E8F0"/>
-          </a:solidFill>
-          <a:ln w="25400">
-            <a:solidFill>
-              <a:srgbClr val="CBD5E1"/>
-            </a:solidFill>
-            <a:prstDash val="solid"/>
-          </a:ln>
-        </p:spPr>
-      </p:sp>
-      <p:sp>
-        <p:nvSpPr>
-          <p:cNvPr id="7" name="Text 4"/>
-          <p:cNvSpPr/>
-          <p:nvPr/>
-        </p:nvSpPr>
-        <p:spPr>
-          <a:xfrm>
-            <a:off x="5943600" y="1828800"/>
-            <a:ext cx="5486400" cy="3657600"/>
-          </a:xfrm>
-          <a:prstGeom prst="rect">
-            <a:avLst/>
-          </a:prstGeom>
-          <a:noFill/>
-          <a:ln/>
-        </p:spPr>
-        <p:txBody>
-          <a:bodyPr wrap="square" rtlCol="0" anchor="ctr"/>
-          <a:lstStyle/>
-          <a:p>
-            <a:pPr algn="ctr" indent="0" marL="0">
-              <a:buNone/>
-            </a:pPr>
-            <a:r>
-              <a:rPr lang="en-US" sz="1800" b="1" dirty="0">
-                <a:solidFill>
-                  <a:srgbClr val="94A3B8"/>
-                </a:solidFill>
-              </a:rPr>
-              <a:t>Paste Screenshot Here</a:t>
-            </a:r>
             <a:endParaRPr lang="en-US" sz="1800" dirty="0"/>
           </a:p>
         </p:txBody>
       </p:sp>
+      <p:pic>
+        <p:nvPicPr>
+          <p:cNvPr id="8" name="Picture 7">
+            <a:extLst>
+              <a:ext uri="{FF2B5EF4-FFF2-40B4-BE49-F238E27FC236}">
+                <a16:creationId xmlns:a16="http://schemas.microsoft.com/office/drawing/2014/main" id="{4B878995-D03E-4C26-C961-97B881EB7DE9}"/>
+              </a:ext>
+            </a:extLst>
+          </p:cNvPr>
+          <p:cNvPicPr>
+            <a:picLocks noChangeAspect="1"/>
+          </p:cNvPicPr>
+          <p:nvPr/>
+        </p:nvPicPr>
+        <p:blipFill>
+          <a:blip r:embed="rId3"/>
+          <a:stretch>
+            <a:fillRect/>
+          </a:stretch>
+        </p:blipFill>
+        <p:spPr>
+          <a:xfrm>
+            <a:off x="4675357" y="1371600"/>
+            <a:ext cx="4240043" cy="1871980"/>
+          </a:xfrm>
+          <a:prstGeom prst="rect">
+            <a:avLst/>
+          </a:prstGeom>
+        </p:spPr>
+      </p:pic>
     </p:spTree>
   </p:cSld>
   <p:clrMapOvr>
@@ -2908,7 +2598,7 @@
         </p:nvSpPr>
         <p:spPr>
           <a:xfrm>
-            <a:off x="457200" y="457200"/>
+            <a:off x="426720" y="345440"/>
             <a:ext cx="8229600" cy="914400"/>
           </a:xfrm>
           <a:prstGeom prst="rect">
@@ -2921,7 +2611,7 @@
           <a:bodyPr wrap="square" rtlCol="0" anchor="ctr"/>
           <a:lstStyle/>
           <a:p>
-            <a:pPr indent="0" marL="0">
+            <a:pPr marL="0" indent="0">
               <a:buNone/>
             </a:pPr>
             <a:r>
@@ -2944,8 +2634,8 @@
         </p:nvSpPr>
         <p:spPr>
           <a:xfrm>
-            <a:off x="457200" y="1371600"/>
-            <a:ext cx="8229600" cy="457200"/>
+            <a:off x="833120" y="2407920"/>
+            <a:ext cx="8229600" cy="558800"/>
           </a:xfrm>
           <a:prstGeom prst="rect">
             <a:avLst/>
@@ -2957,7 +2647,7 @@
           <a:bodyPr wrap="square" rtlCol="0" anchor="ctr"/>
           <a:lstStyle/>
           <a:p>
-            <a:pPr indent="0" marL="0">
+            <a:pPr marL="0" indent="0">
               <a:buNone/>
             </a:pPr>
             <a:r>
@@ -3006,101 +2696,70 @@
                   <a:srgbClr val="333333"/>
                 </a:solidFill>
               </a:rPr>
-              <a:t>Replace the physical Khata Book</a:t>
-            </a:r>
-            <a:pPr indent="0" marL="0">
-              <a:lnSpc>
-                <a:spcPts val="3500"/>
-              </a:lnSpc>
+              <a:t>Replace the physical Khata BookTrack individual customer balancesOne-click settlements</a:t>
+            </a:r>
+            <a:endParaRPr lang="en-US" sz="2000" dirty="0"/>
+          </a:p>
+        </p:txBody>
+      </p:sp>
+      <p:sp>
+        <p:nvSpPr>
+          <p:cNvPr id="7" name="Text 4"/>
+          <p:cNvSpPr/>
+          <p:nvPr/>
+        </p:nvSpPr>
+        <p:spPr>
+          <a:xfrm>
+            <a:off x="5943600" y="1828800"/>
+            <a:ext cx="5486400" cy="3657600"/>
+          </a:xfrm>
+          <a:prstGeom prst="rect">
+            <a:avLst/>
+          </a:prstGeom>
+          <a:noFill/>
+          <a:ln/>
+        </p:spPr>
+        <p:txBody>
+          <a:bodyPr wrap="square" rtlCol="0" anchor="ctr"/>
+          <a:lstStyle/>
+          <a:p>
+            <a:pPr marL="0" indent="0" algn="ctr">
               <a:buNone/>
             </a:pPr>
-            <a:r>
-              <a:rPr lang="en-US" sz="2000" dirty="0">
-                <a:solidFill>
-                  <a:srgbClr val="333333"/>
-                </a:solidFill>
-              </a:rPr>
-              <a:t>Track individual customer balances</a:t>
-            </a:r>
-            <a:pPr indent="0" marL="0">
-              <a:lnSpc>
-                <a:spcPts val="3500"/>
-              </a:lnSpc>
-              <a:buNone/>
-            </a:pPr>
-            <a:r>
-              <a:rPr lang="en-US" sz="2000" dirty="0">
-                <a:solidFill>
-                  <a:srgbClr val="333333"/>
-                </a:solidFill>
-              </a:rPr>
-              <a:t>One-click settlements</a:t>
-            </a:r>
-            <a:endParaRPr lang="en-US" sz="2000" dirty="0"/>
-          </a:p>
-        </p:txBody>
-      </p:sp>
-      <p:sp>
-        <p:nvSpPr>
-          <p:cNvPr id="6" name="Shape 3"/>
-          <p:cNvSpPr/>
-          <p:nvPr/>
-        </p:nvSpPr>
-        <p:spPr>
-          <a:xfrm>
-            <a:off x="5943600" y="1828800"/>
-            <a:ext cx="5486400" cy="3657600"/>
-          </a:xfrm>
-          <a:prstGeom prst="rect">
-            <a:avLst/>
-          </a:prstGeom>
-          <a:solidFill>
-            <a:srgbClr val="E2E8F0"/>
-          </a:solidFill>
-          <a:ln w="25400">
-            <a:solidFill>
-              <a:srgbClr val="CBD5E1"/>
-            </a:solidFill>
-            <a:prstDash val="solid"/>
-          </a:ln>
-        </p:spPr>
-      </p:sp>
-      <p:sp>
-        <p:nvSpPr>
-          <p:cNvPr id="7" name="Text 4"/>
-          <p:cNvSpPr/>
-          <p:nvPr/>
-        </p:nvSpPr>
-        <p:spPr>
-          <a:xfrm>
-            <a:off x="5943600" y="1828800"/>
-            <a:ext cx="5486400" cy="3657600"/>
-          </a:xfrm>
-          <a:prstGeom prst="rect">
-            <a:avLst/>
-          </a:prstGeom>
-          <a:noFill/>
-          <a:ln/>
-        </p:spPr>
-        <p:txBody>
-          <a:bodyPr wrap="square" rtlCol="0" anchor="ctr"/>
-          <a:lstStyle/>
-          <a:p>
-            <a:pPr algn="ctr" indent="0" marL="0">
-              <a:buNone/>
-            </a:pPr>
-            <a:r>
-              <a:rPr lang="en-US" sz="1800" b="1" dirty="0">
-                <a:solidFill>
-                  <a:srgbClr val="94A3B8"/>
-                </a:solidFill>
-              </a:rPr>
-              <a:t>Paste Screenshot Here</a:t>
-            </a:r>
             <a:endParaRPr lang="en-US" sz="1800" dirty="0"/>
           </a:p>
         </p:txBody>
       </p:sp>
+      <p:pic>
+        <p:nvPicPr>
+          <p:cNvPr id="8" name="Picture 7">
+            <a:extLst>
+              <a:ext uri="{FF2B5EF4-FFF2-40B4-BE49-F238E27FC236}">
+                <a16:creationId xmlns:a16="http://schemas.microsoft.com/office/drawing/2014/main" id="{FEB291E2-4295-26D7-518A-9543E8EBC748}"/>
+              </a:ext>
+            </a:extLst>
+          </p:cNvPr>
+          <p:cNvPicPr>
+            <a:picLocks noChangeAspect="1"/>
+          </p:cNvPicPr>
+          <p:nvPr/>
+        </p:nvPicPr>
+        <p:blipFill>
+          <a:blip r:embed="rId3"/>
+          <a:stretch>
+            <a:fillRect/>
+          </a:stretch>
+        </p:blipFill>
+        <p:spPr>
+          <a:xfrm>
+            <a:off x="4917440" y="1107440"/>
+            <a:ext cx="4114800" cy="3951542"/>
+          </a:xfrm>
+          <a:prstGeom prst="rect">
+            <a:avLst/>
+          </a:prstGeom>
+        </p:spPr>
+      </p:pic>
     </p:spTree>
   </p:cSld>
   <p:clrMapOvr>
@@ -3147,7 +2806,7 @@
           <a:bodyPr wrap="square" rtlCol="0" anchor="ctr"/>
           <a:lstStyle/>
           <a:p>
-            <a:pPr indent="0" marL="0">
+            <a:pPr marL="0" indent="0">
               <a:buNone/>
             </a:pPr>
             <a:r>
@@ -3183,7 +2842,7 @@
           <a:bodyPr wrap="square" rtlCol="0" anchor="ctr"/>
           <a:lstStyle/>
           <a:p>
-            <a:pPr indent="0" marL="0">
+            <a:pPr marL="0" indent="0">
               <a:buNone/>
             </a:pPr>
             <a:r>
@@ -3232,101 +2891,70 @@
                   <a:srgbClr val="333333"/>
                 </a:solidFill>
               </a:rPr>
-              <a:t>World-class UI/UX</a:t>
-            </a:r>
-            <a:pPr indent="0" marL="0">
-              <a:lnSpc>
-                <a:spcPts val="3500"/>
-              </a:lnSpc>
+              <a:t>World-class UI/UXSystem-wide Dark Mode supportLightning-fast responsive interface</a:t>
+            </a:r>
+            <a:endParaRPr lang="en-US" sz="2000" dirty="0"/>
+          </a:p>
+        </p:txBody>
+      </p:sp>
+      <p:sp>
+        <p:nvSpPr>
+          <p:cNvPr id="7" name="Text 4"/>
+          <p:cNvSpPr/>
+          <p:nvPr/>
+        </p:nvSpPr>
+        <p:spPr>
+          <a:xfrm>
+            <a:off x="5943600" y="1828800"/>
+            <a:ext cx="5486400" cy="3657600"/>
+          </a:xfrm>
+          <a:prstGeom prst="rect">
+            <a:avLst/>
+          </a:prstGeom>
+          <a:noFill/>
+          <a:ln/>
+        </p:spPr>
+        <p:txBody>
+          <a:bodyPr wrap="square" rtlCol="0" anchor="ctr"/>
+          <a:lstStyle/>
+          <a:p>
+            <a:pPr marL="0" indent="0" algn="ctr">
               <a:buNone/>
             </a:pPr>
-            <a:r>
-              <a:rPr lang="en-US" sz="2000" dirty="0">
-                <a:solidFill>
-                  <a:srgbClr val="333333"/>
-                </a:solidFill>
-              </a:rPr>
-              <a:t>System-wide Dark Mode support</a:t>
-            </a:r>
-            <a:pPr indent="0" marL="0">
-              <a:lnSpc>
-                <a:spcPts val="3500"/>
-              </a:lnSpc>
-              <a:buNone/>
-            </a:pPr>
-            <a:r>
-              <a:rPr lang="en-US" sz="2000" dirty="0">
-                <a:solidFill>
-                  <a:srgbClr val="333333"/>
-                </a:solidFill>
-              </a:rPr>
-              <a:t>Lightning-fast responsive interface</a:t>
-            </a:r>
-            <a:endParaRPr lang="en-US" sz="2000" dirty="0"/>
-          </a:p>
-        </p:txBody>
-      </p:sp>
-      <p:sp>
-        <p:nvSpPr>
-          <p:cNvPr id="6" name="Shape 3"/>
-          <p:cNvSpPr/>
-          <p:nvPr/>
-        </p:nvSpPr>
-        <p:spPr>
-          <a:xfrm>
-            <a:off x="5943600" y="1828800"/>
-            <a:ext cx="5486400" cy="3657600"/>
-          </a:xfrm>
-          <a:prstGeom prst="rect">
-            <a:avLst/>
-          </a:prstGeom>
-          <a:solidFill>
-            <a:srgbClr val="E2E8F0"/>
-          </a:solidFill>
-          <a:ln w="25400">
-            <a:solidFill>
-              <a:srgbClr val="CBD5E1"/>
-            </a:solidFill>
-            <a:prstDash val="solid"/>
-          </a:ln>
-        </p:spPr>
-      </p:sp>
-      <p:sp>
-        <p:nvSpPr>
-          <p:cNvPr id="7" name="Text 4"/>
-          <p:cNvSpPr/>
-          <p:nvPr/>
-        </p:nvSpPr>
-        <p:spPr>
-          <a:xfrm>
-            <a:off x="5943600" y="1828800"/>
-            <a:ext cx="5486400" cy="3657600"/>
-          </a:xfrm>
-          <a:prstGeom prst="rect">
-            <a:avLst/>
-          </a:prstGeom>
-          <a:noFill/>
-          <a:ln/>
-        </p:spPr>
-        <p:txBody>
-          <a:bodyPr wrap="square" rtlCol="0" anchor="ctr"/>
-          <a:lstStyle/>
-          <a:p>
-            <a:pPr algn="ctr" indent="0" marL="0">
-              <a:buNone/>
-            </a:pPr>
-            <a:r>
-              <a:rPr lang="en-US" sz="1800" b="1" dirty="0">
-                <a:solidFill>
-                  <a:srgbClr val="94A3B8"/>
-                </a:solidFill>
-              </a:rPr>
-              <a:t>Paste Screenshot Here</a:t>
-            </a:r>
             <a:endParaRPr lang="en-US" sz="1800" dirty="0"/>
           </a:p>
         </p:txBody>
       </p:sp>
+      <p:pic>
+        <p:nvPicPr>
+          <p:cNvPr id="8" name="Picture 7">
+            <a:extLst>
+              <a:ext uri="{FF2B5EF4-FFF2-40B4-BE49-F238E27FC236}">
+                <a16:creationId xmlns:a16="http://schemas.microsoft.com/office/drawing/2014/main" id="{A9147D8E-CCA6-F3A5-061B-A6961124C6F0}"/>
+              </a:ext>
+            </a:extLst>
+          </p:cNvPr>
+          <p:cNvPicPr>
+            <a:picLocks noChangeAspect="1"/>
+          </p:cNvPicPr>
+          <p:nvPr/>
+        </p:nvPicPr>
+        <p:blipFill>
+          <a:blip r:embed="rId3"/>
+          <a:stretch>
+            <a:fillRect/>
+          </a:stretch>
+        </p:blipFill>
+        <p:spPr>
+          <a:xfrm>
+            <a:off x="257477" y="1927750"/>
+            <a:ext cx="7674005" cy="1272650"/>
+          </a:xfrm>
+          <a:prstGeom prst="rect">
+            <a:avLst/>
+          </a:prstGeom>
+        </p:spPr>
+      </p:pic>
     </p:spTree>
   </p:cSld>
   <p:clrMapOvr>
@@ -3373,7 +3001,7 @@
           <a:bodyPr wrap="square" rtlCol="0" anchor="ctr"/>
           <a:lstStyle/>
           <a:p>
-            <a:pPr indent="0" marL="0">
+            <a:pPr marL="0" indent="0">
               <a:buNone/>
             </a:pPr>
             <a:r>
@@ -3409,7 +3037,7 @@
           <a:bodyPr wrap="square" rtlCol="0" anchor="ctr"/>
           <a:lstStyle/>
           <a:p>
-            <a:pPr indent="0" marL="0">
+            <a:pPr marL="0" indent="0">
               <a:buNone/>
             </a:pPr>
             <a:r>
@@ -3432,8 +3060,8 @@
         </p:nvSpPr>
         <p:spPr>
           <a:xfrm>
-            <a:off x="457200" y="2011680"/>
-            <a:ext cx="5029200" cy="3657600"/>
+            <a:off x="365760" y="1148080"/>
+            <a:ext cx="5029200" cy="3749040"/>
           </a:xfrm>
           <a:prstGeom prst="rect">
             <a:avLst/>
@@ -3458,111 +3086,36 @@
                   <a:srgbClr val="333333"/>
                 </a:solidFill>
               </a:rPr>
-              <a:t>Frontend: React + Vite, Tailwind CSS (v4)</a:t>
-            </a:r>
-            <a:pPr indent="0" marL="0">
-              <a:lnSpc>
-                <a:spcPts val="3500"/>
-              </a:lnSpc>
+              <a:t>Frontend: React + Vite, Tailwind CSS (v4)Animations: Framer MotionBackend: Node.js, Express.jsDatabase: SQLite (Lightweight, local-first)</a:t>
+            </a:r>
+            <a:endParaRPr lang="en-US" sz="2000" dirty="0"/>
+          </a:p>
+        </p:txBody>
+      </p:sp>
+      <p:sp>
+        <p:nvSpPr>
+          <p:cNvPr id="7" name="Text 4"/>
+          <p:cNvSpPr/>
+          <p:nvPr/>
+        </p:nvSpPr>
+        <p:spPr>
+          <a:xfrm>
+            <a:off x="5943600" y="1828800"/>
+            <a:ext cx="5486400" cy="3657600"/>
+          </a:xfrm>
+          <a:prstGeom prst="rect">
+            <a:avLst/>
+          </a:prstGeom>
+          <a:noFill/>
+          <a:ln/>
+        </p:spPr>
+        <p:txBody>
+          <a:bodyPr wrap="square" rtlCol="0" anchor="ctr"/>
+          <a:lstStyle/>
+          <a:p>
+            <a:pPr marL="0" indent="0" algn="ctr">
               <a:buNone/>
             </a:pPr>
-            <a:r>
-              <a:rPr lang="en-US" sz="2000" dirty="0">
-                <a:solidFill>
-                  <a:srgbClr val="333333"/>
-                </a:solidFill>
-              </a:rPr>
-              <a:t>Animations: Framer Motion</a:t>
-            </a:r>
-            <a:pPr indent="0" marL="0">
-              <a:lnSpc>
-                <a:spcPts val="3500"/>
-              </a:lnSpc>
-              <a:buNone/>
-            </a:pPr>
-            <a:r>
-              <a:rPr lang="en-US" sz="2000" dirty="0">
-                <a:solidFill>
-                  <a:srgbClr val="333333"/>
-                </a:solidFill>
-              </a:rPr>
-              <a:t>Backend: Node.js, Express.js</a:t>
-            </a:r>
-            <a:pPr indent="0" marL="0">
-              <a:lnSpc>
-                <a:spcPts val="3500"/>
-              </a:lnSpc>
-              <a:buNone/>
-            </a:pPr>
-            <a:r>
-              <a:rPr lang="en-US" sz="2000" dirty="0">
-                <a:solidFill>
-                  <a:srgbClr val="333333"/>
-                </a:solidFill>
-              </a:rPr>
-              <a:t>Database: SQLite (Lightweight, local-first)</a:t>
-            </a:r>
-            <a:endParaRPr lang="en-US" sz="2000" dirty="0"/>
-          </a:p>
-        </p:txBody>
-      </p:sp>
-      <p:sp>
-        <p:nvSpPr>
-          <p:cNvPr id="6" name="Shape 3"/>
-          <p:cNvSpPr/>
-          <p:nvPr/>
-        </p:nvSpPr>
-        <p:spPr>
-          <a:xfrm>
-            <a:off x="5943600" y="1828800"/>
-            <a:ext cx="5486400" cy="3657600"/>
-          </a:xfrm>
-          <a:prstGeom prst="rect">
-            <a:avLst/>
-          </a:prstGeom>
-          <a:solidFill>
-            <a:srgbClr val="E2E8F0"/>
-          </a:solidFill>
-          <a:ln w="25400">
-            <a:solidFill>
-              <a:srgbClr val="CBD5E1"/>
-            </a:solidFill>
-            <a:prstDash val="solid"/>
-          </a:ln>
-        </p:spPr>
-      </p:sp>
-      <p:sp>
-        <p:nvSpPr>
-          <p:cNvPr id="7" name="Text 4"/>
-          <p:cNvSpPr/>
-          <p:nvPr/>
-        </p:nvSpPr>
-        <p:spPr>
-          <a:xfrm>
-            <a:off x="5943600" y="1828800"/>
-            <a:ext cx="5486400" cy="3657600"/>
-          </a:xfrm>
-          <a:prstGeom prst="rect">
-            <a:avLst/>
-          </a:prstGeom>
-          <a:noFill/>
-          <a:ln/>
-        </p:spPr>
-        <p:txBody>
-          <a:bodyPr wrap="square" rtlCol="0" anchor="ctr"/>
-          <a:lstStyle/>
-          <a:p>
-            <a:pPr algn="ctr" indent="0" marL="0">
-              <a:buNone/>
-            </a:pPr>
-            <a:r>
-              <a:rPr lang="en-US" sz="1800" b="1" dirty="0">
-                <a:solidFill>
-                  <a:srgbClr val="94A3B8"/>
-                </a:solidFill>
-              </a:rPr>
-              <a:t>Paste Screenshot Here</a:t>
-            </a:r>
             <a:endParaRPr lang="en-US" sz="1800" dirty="0"/>
           </a:p>
         </p:txBody>
@@ -3613,7 +3166,7 @@
           <a:bodyPr wrap="square" rtlCol="0" anchor="ctr"/>
           <a:lstStyle/>
           <a:p>
-            <a:pPr indent="0" marL="0">
+            <a:pPr marL="0" indent="0">
               <a:buNone/>
             </a:pPr>
             <a:r>
@@ -3636,7 +3189,7 @@
         </p:nvSpPr>
         <p:spPr>
           <a:xfrm>
-            <a:off x="457200" y="1371600"/>
+            <a:off x="457200" y="1270000"/>
             <a:ext cx="8229600" cy="457200"/>
           </a:xfrm>
           <a:prstGeom prst="rect">
@@ -3649,7 +3202,7 @@
           <a:bodyPr wrap="square" rtlCol="0" anchor="ctr"/>
           <a:lstStyle/>
           <a:p>
-            <a:pPr indent="0" marL="0">
+            <a:pPr marL="0" indent="0">
               <a:buNone/>
             </a:pPr>
             <a:r>
@@ -3672,7 +3225,7 @@
         </p:nvSpPr>
         <p:spPr>
           <a:xfrm>
-            <a:off x="457200" y="2011680"/>
+            <a:off x="457200" y="2275840"/>
             <a:ext cx="5029200" cy="3657600"/>
           </a:xfrm>
           <a:prstGeom prst="rect">
@@ -3698,101 +3251,70 @@
                   <a:srgbClr val="333333"/>
                 </a:solidFill>
               </a:rPr>
-              <a:t>Direct WhatsApp Integration (receipts)</a:t>
-            </a:r>
-            <a:pPr indent="0" marL="0">
-              <a:lnSpc>
-                <a:spcPts val="3500"/>
-              </a:lnSpc>
+              <a:t>Direct Integration (receipts)Native Android/iOS App deploymentPredictive AI (Stock alerts)</a:t>
+            </a:r>
+            <a:endParaRPr lang="en-US" sz="2000" dirty="0"/>
+          </a:p>
+        </p:txBody>
+      </p:sp>
+      <p:sp>
+        <p:nvSpPr>
+          <p:cNvPr id="7" name="Text 4"/>
+          <p:cNvSpPr/>
+          <p:nvPr/>
+        </p:nvSpPr>
+        <p:spPr>
+          <a:xfrm>
+            <a:off x="5943600" y="1828800"/>
+            <a:ext cx="5486400" cy="3657600"/>
+          </a:xfrm>
+          <a:prstGeom prst="rect">
+            <a:avLst/>
+          </a:prstGeom>
+          <a:noFill/>
+          <a:ln/>
+        </p:spPr>
+        <p:txBody>
+          <a:bodyPr wrap="square" rtlCol="0" anchor="ctr"/>
+          <a:lstStyle/>
+          <a:p>
+            <a:pPr marL="0" indent="0" algn="ctr">
               <a:buNone/>
             </a:pPr>
-            <a:r>
-              <a:rPr lang="en-US" sz="2000" dirty="0">
-                <a:solidFill>
-                  <a:srgbClr val="333333"/>
-                </a:solidFill>
-              </a:rPr>
-              <a:t>Native Android/iOS App deployment</a:t>
-            </a:r>
-            <a:pPr indent="0" marL="0">
-              <a:lnSpc>
-                <a:spcPts val="3500"/>
-              </a:lnSpc>
-              <a:buNone/>
-            </a:pPr>
-            <a:r>
-              <a:rPr lang="en-US" sz="2000" dirty="0">
-                <a:solidFill>
-                  <a:srgbClr val="333333"/>
-                </a:solidFill>
-              </a:rPr>
-              <a:t>Predictive AI (Stock alerts)</a:t>
-            </a:r>
-            <a:endParaRPr lang="en-US" sz="2000" dirty="0"/>
-          </a:p>
-        </p:txBody>
-      </p:sp>
-      <p:sp>
-        <p:nvSpPr>
-          <p:cNvPr id="6" name="Shape 3"/>
-          <p:cNvSpPr/>
-          <p:nvPr/>
-        </p:nvSpPr>
-        <p:spPr>
-          <a:xfrm>
-            <a:off x="5943600" y="1828800"/>
-            <a:ext cx="5486400" cy="3657600"/>
-          </a:xfrm>
-          <a:prstGeom prst="rect">
-            <a:avLst/>
-          </a:prstGeom>
-          <a:solidFill>
-            <a:srgbClr val="E2E8F0"/>
-          </a:solidFill>
-          <a:ln w="25400">
-            <a:solidFill>
-              <a:srgbClr val="CBD5E1"/>
-            </a:solidFill>
-            <a:prstDash val="solid"/>
-          </a:ln>
-        </p:spPr>
-      </p:sp>
-      <p:sp>
-        <p:nvSpPr>
-          <p:cNvPr id="7" name="Text 4"/>
-          <p:cNvSpPr/>
-          <p:nvPr/>
-        </p:nvSpPr>
-        <p:spPr>
-          <a:xfrm>
-            <a:off x="5943600" y="1828800"/>
-            <a:ext cx="5486400" cy="3657600"/>
-          </a:xfrm>
-          <a:prstGeom prst="rect">
-            <a:avLst/>
-          </a:prstGeom>
-          <a:noFill/>
-          <a:ln/>
-        </p:spPr>
-        <p:txBody>
-          <a:bodyPr wrap="square" rtlCol="0" anchor="ctr"/>
-          <a:lstStyle/>
-          <a:p>
-            <a:pPr algn="ctr" indent="0" marL="0">
-              <a:buNone/>
-            </a:pPr>
-            <a:r>
-              <a:rPr lang="en-US" sz="1800" b="1" dirty="0">
-                <a:solidFill>
-                  <a:srgbClr val="94A3B8"/>
-                </a:solidFill>
-              </a:rPr>
-              <a:t>Paste Screenshot Here</a:t>
-            </a:r>
             <a:endParaRPr lang="en-US" sz="1800" dirty="0"/>
           </a:p>
         </p:txBody>
       </p:sp>
+      <p:pic>
+        <p:nvPicPr>
+          <p:cNvPr id="8" name="Picture 7">
+            <a:extLst>
+              <a:ext uri="{FF2B5EF4-FFF2-40B4-BE49-F238E27FC236}">
+                <a16:creationId xmlns:a16="http://schemas.microsoft.com/office/drawing/2014/main" id="{C93A5BB2-199A-D439-A048-AD4758DAA191}"/>
+              </a:ext>
+            </a:extLst>
+          </p:cNvPr>
+          <p:cNvPicPr>
+            <a:picLocks noChangeAspect="1"/>
+          </p:cNvPicPr>
+          <p:nvPr/>
+        </p:nvPicPr>
+        <p:blipFill>
+          <a:blip r:embed="rId3"/>
+          <a:stretch>
+            <a:fillRect/>
+          </a:stretch>
+        </p:blipFill>
+        <p:spPr>
+          <a:xfrm>
+            <a:off x="497840" y="1788160"/>
+            <a:ext cx="5405120" cy="1717040"/>
+          </a:xfrm>
+          <a:prstGeom prst="rect">
+            <a:avLst/>
+          </a:prstGeom>
+        </p:spPr>
+      </p:pic>
     </p:spTree>
   </p:cSld>
   <p:clrMapOvr>
@@ -4094,4 +3616,299 @@
     </a:ext>
   </a:extLst>
 </a:theme>
+</file>
+
+<file path=ppt/theme/theme2.xml><?xml version="1.0" encoding="utf-8"?>
+<a:theme xmlns:a="http://schemas.openxmlformats.org/drawingml/2006/main" name="Office Theme">
+  <a:themeElements>
+    <a:clrScheme name="Office">
+      <a:dk1>
+        <a:sysClr val="windowText" lastClr="000000"/>
+      </a:dk1>
+      <a:lt1>
+        <a:sysClr val="window" lastClr="FFFFFF"/>
+      </a:lt1>
+      <a:dk2>
+        <a:srgbClr val="44546A"/>
+      </a:dk2>
+      <a:lt2>
+        <a:srgbClr val="E7E6E6"/>
+      </a:lt2>
+      <a:accent1>
+        <a:srgbClr val="4472C4"/>
+      </a:accent1>
+      <a:accent2>
+        <a:srgbClr val="ED7D31"/>
+      </a:accent2>
+      <a:accent3>
+        <a:srgbClr val="A5A5A5"/>
+      </a:accent3>
+      <a:accent4>
+        <a:srgbClr val="FFC000"/>
+      </a:accent4>
+      <a:accent5>
+        <a:srgbClr val="5B9BD5"/>
+      </a:accent5>
+      <a:accent6>
+        <a:srgbClr val="70AD47"/>
+      </a:accent6>
+      <a:hlink>
+        <a:srgbClr val="0563C1"/>
+      </a:hlink>
+      <a:folHlink>
+        <a:srgbClr val="954F72"/>
+      </a:folHlink>
+    </a:clrScheme>
+    <a:fontScheme name="Office">
+      <a:majorFont>
+        <a:latin typeface="Calibri Light" panose="020F0302020204030204"/>
+        <a:ea typeface=""/>
+        <a:cs typeface=""/>
+        <a:font script="Jpan" typeface="游ゴシック Light"/>
+        <a:font script="Hang" typeface="맑은 고딕"/>
+        <a:font script="Hans" typeface="等线 Light"/>
+        <a:font script="Hant" typeface="新細明體"/>
+        <a:font script="Arab" typeface="Times New Roman"/>
+        <a:font script="Hebr" typeface="Times New Roman"/>
+        <a:font script="Thai" typeface="Angsana New"/>
+        <a:font script="Ethi" typeface="Nyala"/>
+        <a:font script="Beng" typeface="Vrinda"/>
+        <a:font script="Gujr" typeface="Shruti"/>
+        <a:font script="Khmr" typeface="MoolBoran"/>
+        <a:font script="Knda" typeface="Tunga"/>
+        <a:font script="Guru" typeface="Raavi"/>
+        <a:font script="Cans" typeface="Euphemia"/>
+        <a:font script="Cher" typeface="Plantagenet Cherokee"/>
+        <a:font script="Yiii" typeface="Microsoft Yi Baiti"/>
+        <a:font script="Tibt" typeface="Microsoft Himalaya"/>
+        <a:font script="Thaa" typeface="MV Boli"/>
+        <a:font script="Deva" typeface="Mangal"/>
+        <a:font script="Telu" typeface="Gautami"/>
+        <a:font script="Taml" typeface="Latha"/>
+        <a:font script="Syrc" typeface="Estrangelo Edessa"/>
+        <a:font script="Orya" typeface="Kalinga"/>
+        <a:font script="Mlym" typeface="Kartika"/>
+        <a:font script="Laoo" typeface="DokChampa"/>
+        <a:font script="Sinh" typeface="Iskoola Pota"/>
+        <a:font script="Mong" typeface="Mongolian Baiti"/>
+        <a:font script="Viet" typeface="Times New Roman"/>
+        <a:font script="Uigh" typeface="Microsoft Uighur"/>
+        <a:font script="Geor" typeface="Sylfaen"/>
+        <a:font script="Armn" typeface="Arial"/>
+        <a:font script="Bugi" typeface="Leelawadee UI"/>
+        <a:font script="Bopo" typeface="Microsoft JhengHei"/>
+        <a:font script="Java" typeface="Javanese Text"/>
+        <a:font script="Lisu" typeface="Segoe UI"/>
+        <a:font script="Mymr" typeface="Myanmar Text"/>
+        <a:font script="Nkoo" typeface="Ebrima"/>
+        <a:font script="Olck" typeface="Nirmala UI"/>
+        <a:font script="Osma" typeface="Ebrima"/>
+        <a:font script="Phag" typeface="Phagspa"/>
+        <a:font script="Syrn" typeface="Estrangelo Edessa"/>
+        <a:font script="Syrj" typeface="Estrangelo Edessa"/>
+        <a:font script="Syre" typeface="Estrangelo Edessa"/>
+        <a:font script="Sora" typeface="Nirmala UI"/>
+        <a:font script="Tale" typeface="Microsoft Tai Le"/>
+        <a:font script="Talu" typeface="Microsoft New Tai Lue"/>
+        <a:font script="Tfng" typeface="Ebrima"/>
+      </a:majorFont>
+      <a:minorFont>
+        <a:latin typeface="Calibri" panose="020F0502020204030204"/>
+        <a:ea typeface=""/>
+        <a:cs typeface=""/>
+        <a:font script="Jpan" typeface="游ゴシック"/>
+        <a:font script="Hang" typeface="맑은 고딕"/>
+        <a:font script="Hans" typeface="等线"/>
+        <a:font script="Hant" typeface="新細明體"/>
+        <a:font script="Arab" typeface="Arial"/>
+        <a:font script="Hebr" typeface="Arial"/>
+        <a:font script="Thai" typeface="Cordia New"/>
+        <a:font script="Ethi" typeface="Nyala"/>
+        <a:font script="Beng" typeface="Vrinda"/>
+        <a:font script="Gujr" typeface="Shruti"/>
+        <a:font script="Khmr" typeface="DaunPenh"/>
+        <a:font script="Knda" typeface="Tunga"/>
+        <a:font script="Guru" typeface="Raavi"/>
+        <a:font script="Cans" typeface="Euphemia"/>
+        <a:font script="Cher" typeface="Plantagenet Cherokee"/>
+        <a:font script="Yiii" typeface="Microsoft Yi Baiti"/>
+        <a:font script="Tibt" typeface="Microsoft Himalaya"/>
+        <a:font script="Thaa" typeface="MV Boli"/>
+        <a:font script="Deva" typeface="Mangal"/>
+        <a:font script="Telu" typeface="Gautami"/>
+        <a:font script="Taml" typeface="Latha"/>
+        <a:font script="Syrc" typeface="Estrangelo Edessa"/>
+        <a:font script="Orya" typeface="Kalinga"/>
+        <a:font script="Mlym" typeface="Kartika"/>
+        <a:font script="Laoo" typeface="DokChampa"/>
+        <a:font script="Sinh" typeface="Iskoola Pota"/>
+        <a:font script="Mong" typeface="Mongolian Baiti"/>
+        <a:font script="Viet" typeface="Arial"/>
+        <a:font script="Uigh" typeface="Microsoft Uighur"/>
+        <a:font script="Geor" typeface="Sylfaen"/>
+        <a:font script="Armn" typeface="Arial"/>
+        <a:font script="Bugi" typeface="Leelawadee UI"/>
+        <a:font script="Bopo" typeface="Microsoft JhengHei"/>
+        <a:font script="Java" typeface="Javanese Text"/>
+        <a:font script="Lisu" typeface="Segoe UI"/>
+        <a:font script="Mymr" typeface="Myanmar Text"/>
+        <a:font script="Nkoo" typeface="Ebrima"/>
+        <a:font script="Olck" typeface="Nirmala UI"/>
+        <a:font script="Osma" typeface="Ebrima"/>
+        <a:font script="Phag" typeface="Phagspa"/>
+        <a:font script="Syrn" typeface="Estrangelo Edessa"/>
+        <a:font script="Syrj" typeface="Estrangelo Edessa"/>
+        <a:font script="Syre" typeface="Estrangelo Edessa"/>
+        <a:font script="Sora" typeface="Nirmala UI"/>
+        <a:font script="Tale" typeface="Microsoft Tai Le"/>
+        <a:font script="Talu" typeface="Microsoft New Tai Lue"/>
+        <a:font script="Tfng" typeface="Ebrima"/>
+      </a:minorFont>
+    </a:fontScheme>
+    <a:fmtScheme name="Office">
+      <a:fillStyleLst>
+        <a:solidFill>
+          <a:schemeClr val="phClr"/>
+        </a:solidFill>
+        <a:gradFill rotWithShape="1">
+          <a:gsLst>
+            <a:gs pos="0">
+              <a:schemeClr val="phClr">
+                <a:lumMod val="110000"/>
+                <a:satMod val="105000"/>
+                <a:tint val="67000"/>
+              </a:schemeClr>
+            </a:gs>
+            <a:gs pos="50000">
+              <a:schemeClr val="phClr">
+                <a:lumMod val="105000"/>
+                <a:satMod val="103000"/>
+                <a:tint val="73000"/>
+              </a:schemeClr>
+            </a:gs>
+            <a:gs pos="100000">
+              <a:schemeClr val="phClr">
+                <a:lumMod val="105000"/>
+                <a:satMod val="109000"/>
+                <a:tint val="81000"/>
+              </a:schemeClr>
+            </a:gs>
+          </a:gsLst>
+          <a:lin ang="5400000" scaled="0"/>
+        </a:gradFill>
+        <a:gradFill rotWithShape="1">
+          <a:gsLst>
+            <a:gs pos="0">
+              <a:schemeClr val="phClr">
+                <a:satMod val="103000"/>
+                <a:lumMod val="102000"/>
+                <a:tint val="94000"/>
+              </a:schemeClr>
+            </a:gs>
+            <a:gs pos="50000">
+              <a:schemeClr val="phClr">
+                <a:satMod val="110000"/>
+                <a:lumMod val="100000"/>
+                <a:shade val="100000"/>
+              </a:schemeClr>
+            </a:gs>
+            <a:gs pos="100000">
+              <a:schemeClr val="phClr">
+                <a:lumMod val="99000"/>
+                <a:satMod val="120000"/>
+                <a:shade val="78000"/>
+              </a:schemeClr>
+            </a:gs>
+          </a:gsLst>
+          <a:lin ang="5400000" scaled="0"/>
+        </a:gradFill>
+      </a:fillStyleLst>
+      <a:lnStyleLst>
+        <a:ln w="6350" cap="flat" cmpd="sng" algn="ctr">
+          <a:solidFill>
+            <a:schemeClr val="phClr"/>
+          </a:solidFill>
+          <a:prstDash val="solid"/>
+          <a:miter lim="800000"/>
+        </a:ln>
+        <a:ln w="12700" cap="flat" cmpd="sng" algn="ctr">
+          <a:solidFill>
+            <a:schemeClr val="phClr"/>
+          </a:solidFill>
+          <a:prstDash val="solid"/>
+          <a:miter lim="800000"/>
+        </a:ln>
+        <a:ln w="19050" cap="flat" cmpd="sng" algn="ctr">
+          <a:solidFill>
+            <a:schemeClr val="phClr"/>
+          </a:solidFill>
+          <a:prstDash val="solid"/>
+          <a:miter lim="800000"/>
+        </a:ln>
+      </a:lnStyleLst>
+      <a:effectStyleLst>
+        <a:effectStyle>
+          <a:effectLst/>
+        </a:effectStyle>
+        <a:effectStyle>
+          <a:effectLst/>
+        </a:effectStyle>
+        <a:effectStyle>
+          <a:effectLst>
+            <a:outerShdw blurRad="57150" dist="19050" dir="5400000" algn="ctr" rotWithShape="0">
+              <a:srgbClr val="000000">
+                <a:alpha val="63000"/>
+              </a:srgbClr>
+            </a:outerShdw>
+          </a:effectLst>
+        </a:effectStyle>
+      </a:effectStyleLst>
+      <a:bgFillStyleLst>
+        <a:solidFill>
+          <a:schemeClr val="phClr"/>
+        </a:solidFill>
+        <a:solidFill>
+          <a:schemeClr val="phClr">
+            <a:tint val="95000"/>
+            <a:satMod val="170000"/>
+          </a:schemeClr>
+        </a:solidFill>
+        <a:gradFill rotWithShape="1">
+          <a:gsLst>
+            <a:gs pos="0">
+              <a:schemeClr val="phClr">
+                <a:tint val="93000"/>
+                <a:satMod val="150000"/>
+                <a:shade val="98000"/>
+                <a:lumMod val="102000"/>
+              </a:schemeClr>
+            </a:gs>
+            <a:gs pos="50000">
+              <a:schemeClr val="phClr">
+                <a:tint val="98000"/>
+                <a:satMod val="130000"/>
+                <a:shade val="90000"/>
+                <a:lumMod val="103000"/>
+              </a:schemeClr>
+            </a:gs>
+            <a:gs pos="100000">
+              <a:schemeClr val="phClr">
+                <a:shade val="63000"/>
+                <a:satMod val="120000"/>
+              </a:schemeClr>
+            </a:gs>
+          </a:gsLst>
+          <a:lin ang="5400000" scaled="0"/>
+        </a:gradFill>
+      </a:bgFillStyleLst>
+    </a:fmtScheme>
+  </a:themeElements>
+  <a:objectDefaults/>
+  <a:extraClrSchemeLst/>
+  <a:extLst>
+    <a:ext uri="{05A4C25C-085E-4340-85A3-A5531E510DB2}">
+      <thm15:themeFamily xmlns:thm15="http://schemas.microsoft.com/office/thememl/2012/main" name="Office Theme" id="{62F939B6-93AF-4DB8-9C6B-D6C7DFDC589F}" vid="{4A3C46E8-61CC-4603-A589-7422A47A8E4A}"/>
+    </a:ext>
+  </a:extLst>
+</a:theme>
 </file>
</xml_diff>